<commit_message>
fix(presentation): resolve table overlaps, text wrapping, axis label clashing, and 2x2 confusion matrix grid
</commit_message>
<xml_diff>
--- a/midlab_ml_experiment/Data_Networks_Final_Evaluation_Presentation.pptx
+++ b/midlab_ml_experiment/Data_Networks_Final_Evaluation_Presentation.pptx
@@ -3143,7 +3143,7 @@
         <p:spPr>
           <a:xfrm>
             <a:off x="0" y="0"/>
-            <a:ext cx="12191695" cy="1645920"/>
+            <a:ext cx="12191695" cy="1600200"/>
           </a:xfrm>
           <a:prstGeom prst="rect">
             <a:avLst/>
@@ -3185,8 +3185,8 @@
         </p:nvSpPr>
         <p:spPr>
           <a:xfrm>
-            <a:off x="0" y="1645920"/>
-            <a:ext cx="12191695" cy="54864"/>
+            <a:off x="0" y="1600200"/>
+            <a:ext cx="12191695" cy="45720"/>
           </a:xfrm>
           <a:prstGeom prst="rect">
             <a:avLst/>
@@ -3228,7 +3228,7 @@
         </p:nvSpPr>
         <p:spPr>
           <a:xfrm>
-            <a:off x="548640" y="91440"/>
+            <a:off x="548640" y="73152"/>
             <a:ext cx="11094415" cy="777240"/>
           </a:xfrm>
           <a:prstGeom prst="rect">
@@ -3243,7 +3243,7 @@
           <a:lstStyle/>
           <a:p>
             <a:pPr>
-              <a:defRPr sz="2200" b="1">
+              <a:defRPr sz="2100" b="1">
                 <a:solidFill>
                   <a:srgbClr val="FFFFFF"/>
                 </a:solidFill>
@@ -3256,7 +3256,7 @@
           </a:p>
           <a:p>
             <a:pPr>
-              <a:defRPr sz="1300" b="1">
+              <a:defRPr sz="1250" b="1">
                 <a:solidFill>
                   <a:srgbClr val="0EA5E9"/>
                 </a:solidFill>
@@ -3277,7 +3277,7 @@
         </p:nvSpPr>
         <p:spPr>
           <a:xfrm>
-            <a:off x="548640" y="914400"/>
+            <a:off x="548640" y="868680"/>
             <a:ext cx="11094415" cy="640080"/>
           </a:xfrm>
           <a:prstGeom prst="rect">
@@ -3292,7 +3292,7 @@
           <a:lstStyle/>
           <a:p>
             <a:pPr>
-              <a:defRPr sz="1200" b="1">
+              <a:defRPr sz="1150" b="1">
                 <a:solidFill>
                   <a:srgbClr val="F1F5F9"/>
                 </a:solidFill>
@@ -3305,7 +3305,7 @@
           </a:p>
           <a:p>
             <a:pPr>
-              <a:defRPr sz="1100">
+              <a:defRPr sz="1050">
                 <a:solidFill>
                   <a:srgbClr val="94A3B8"/>
                 </a:solidFill>
@@ -3313,7 +3313,7 @@
               </a:defRPr>
             </a:pPr>
             <a:r>
-              <a:t>Department of Electronics and Communication Engineering  |  National Institute of Technology Warangal</a:t>
+              <a:t>Department of Electronics and Communication Engineering  •  National Institute of Technology Warangal</a:t>
             </a:r>
           </a:p>
         </p:txBody>
@@ -3326,8 +3326,8 @@
         </p:nvSpPr>
         <p:spPr>
           <a:xfrm>
-            <a:off x="548640" y="1828800"/>
-            <a:ext cx="5303520" cy="4754880"/>
+            <a:off x="548640" y="1783080"/>
+            <a:ext cx="5303520" cy="4846320"/>
           </a:xfrm>
           <a:prstGeom prst="rect">
             <a:avLst/>
@@ -3335,7 +3335,7 @@
           <a:solidFill>
             <a:srgbClr val="FFFFFF"/>
           </a:solidFill>
-          <a:ln w="15240">
+          <a:ln w="13970">
             <a:solidFill>
               <a:srgbClr val="CBD5E1"/>
             </a:solidFill>
@@ -3371,7 +3371,7 @@
         </p:nvSpPr>
         <p:spPr>
           <a:xfrm>
-            <a:off x="731520" y="1920240"/>
+            <a:off x="731520" y="1874519"/>
             <a:ext cx="4937760" cy="365760"/>
           </a:xfrm>
           <a:prstGeom prst="rect">
@@ -3386,7 +3386,7 @@
           <a:lstStyle/>
           <a:p>
             <a:pPr>
-              <a:defRPr sz="1600" b="1">
+              <a:defRPr sz="1550" b="1">
                 <a:solidFill>
                   <a:srgbClr val="1E3A8A"/>
                 </a:solidFill>
@@ -3407,8 +3407,8 @@
         </p:nvSpPr>
         <p:spPr>
           <a:xfrm>
-            <a:off x="731520" y="2331720"/>
-            <a:ext cx="4937760" cy="4114800"/>
+            <a:off x="731520" y="2286000"/>
+            <a:ext cx="4937760" cy="4206240"/>
           </a:xfrm>
           <a:prstGeom prst="rect">
             <a:avLst/>
@@ -3422,7 +3422,7 @@
           <a:lstStyle/>
           <a:p>
             <a:pPr>
-              <a:defRPr sz="1250" b="1">
+              <a:defRPr sz="1200" b="1">
                 <a:solidFill>
                   <a:srgbClr val="2563EB"/>
                 </a:solidFill>
@@ -3435,7 +3435,7 @@
           </a:p>
           <a:p>
             <a:pPr>
-              <a:defRPr sz="1100">
+              <a:defRPr sz="1050">
                 <a:solidFill>
                   <a:srgbClr val="1E293B"/>
                 </a:solidFill>
@@ -3443,12 +3443,12 @@
               </a:defRPr>
             </a:pPr>
             <a:r>
-              <a:t>IoT networks generate massive flow volumes, but individual edge gateways have strict CPU and memory constraints. Sending raw traffic to cloud servers introduces latency, bandwidth bottlenecks, and security vulnerabilities.</a:t>
+              <a:t>IoT networks generate massive flow volumes, but individual edge gateways have strict CPU and memory limits. Offloading all traffic to cloud servers causes latency, bandwidth bottlenecks, and security vulnerabilities.</a:t>
             </a:r>
           </a:p>
           <a:p>
             <a:pPr>
-              <a:defRPr sz="1250" b="1">
+              <a:defRPr sz="1200" b="1">
                 <a:solidFill>
                   <a:srgbClr val="2563EB"/>
                 </a:solidFill>
@@ -3461,7 +3461,7 @@
           </a:p>
           <a:p>
             <a:pPr>
-              <a:defRPr sz="1100">
+              <a:defRPr sz="1050">
                 <a:solidFill>
                   <a:srgbClr val="1E293B"/>
                 </a:solidFill>
@@ -3469,12 +3469,12 @@
               </a:defRPr>
             </a:pPr>
             <a:r>
-              <a:t>Recent IEEE studies propose deep sequential models (CNN-LSTM with Attention). While highly accurate, they demand over 500,000 parameters and complex matrix unrolling, causing unacceptable packet drop at line rate.</a:t>
+              <a:t>Recent IEEE works deploy deep sequential models (CNN-LSTM with Attention). While highly accurate, they demand over 500,000 parameters and complex recurrent unrolling, leading to packet drops at line rate.</a:t>
             </a:r>
           </a:p>
           <a:p>
             <a:pPr>
-              <a:defRPr sz="1250" b="1">
+              <a:defRPr sz="1200" b="1">
                 <a:solidFill>
                   <a:srgbClr val="2563EB"/>
                 </a:solidFill>
@@ -3487,7 +3487,7 @@
           </a:p>
           <a:p>
             <a:pPr>
-              <a:defRPr sz="1100">
+              <a:defRPr sz="1050">
                 <a:solidFill>
                   <a:srgbClr val="1E293B"/>
                 </a:solidFill>
@@ -3508,8 +3508,8 @@
         </p:nvSpPr>
         <p:spPr>
           <a:xfrm>
-            <a:off x="6035040" y="1828800"/>
-            <a:ext cx="5577840" cy="4754880"/>
+            <a:off x="6035040" y="1783080"/>
+            <a:ext cx="5577840" cy="4846320"/>
           </a:xfrm>
           <a:prstGeom prst="rect">
             <a:avLst/>
@@ -3517,7 +3517,7 @@
           <a:solidFill>
             <a:srgbClr val="FFFFFF"/>
           </a:solidFill>
-          <a:ln w="15240">
+          <a:ln w="13970">
             <a:solidFill>
               <a:srgbClr val="CBD5E1"/>
             </a:solidFill>
@@ -3553,7 +3553,7 @@
         </p:nvSpPr>
         <p:spPr>
           <a:xfrm>
-            <a:off x="6217920" y="1920240"/>
+            <a:off x="6217920" y="1874519"/>
             <a:ext cx="5212080" cy="365760"/>
           </a:xfrm>
           <a:prstGeom prst="rect">
@@ -3568,7 +3568,7 @@
           <a:lstStyle/>
           <a:p>
             <a:pPr>
-              <a:defRPr sz="1600" b="1">
+              <a:defRPr sz="1550" b="1">
                 <a:solidFill>
                   <a:srgbClr val="1E3A8A"/>
                 </a:solidFill>
@@ -3589,8 +3589,8 @@
         </p:nvSpPr>
         <p:spPr>
           <a:xfrm>
-            <a:off x="6217920" y="2331720"/>
-            <a:ext cx="5212080" cy="1645920"/>
+            <a:off x="6217920" y="2286000"/>
+            <a:ext cx="5212080" cy="1463040"/>
           </a:xfrm>
           <a:prstGeom prst="rect">
             <a:avLst/>
@@ -3604,7 +3604,7 @@
           <a:lstStyle/>
           <a:p>
             <a:pPr>
-              <a:defRPr sz="1250" b="1">
+              <a:defRPr sz="1200" b="1">
                 <a:solidFill>
                   <a:srgbClr val="C2410C"/>
                 </a:solidFill>
@@ -3617,7 +3617,7 @@
           </a:p>
           <a:p>
             <a:pPr>
-              <a:defRPr sz="1100">
+              <a:defRPr sz="1050">
                 <a:solidFill>
                   <a:srgbClr val="475569"/>
                 </a:solidFill>
@@ -3629,7 +3629,7 @@
           </a:p>
           <a:p>
             <a:pPr>
-              <a:defRPr sz="1100">
+              <a:defRPr sz="1050">
                 <a:solidFill>
                   <a:srgbClr val="1E293B"/>
                 </a:solidFill>
@@ -3650,8 +3650,8 @@
           <p:nvPr/>
         </p:nvGraphicFramePr>
         <p:xfrm>
-          <a:off x="6217920" y="3977639"/>
-          <a:ext cx="5212080" cy="2377440"/>
+          <a:off x="6217920" y="3886200"/>
+          <a:ext cx="5212080" cy="2468880"/>
         </p:xfrm>
         <a:graphic>
           <a:graphicData uri="http://schemas.openxmlformats.org/drawingml/2006/table">
@@ -3664,14 +3664,14 @@
                 <a:gridCol w="1554480"/>
                 <a:gridCol w="1554480"/>
               </a:tblGrid>
-              <a:tr h="396240">
+              <a:tr h="411480">
                 <a:tc>
                   <a:txBody>
                     <a:bodyPr/>
                     <a:lstStyle/>
                     <a:p>
                       <a:pPr algn="ctr">
-                        <a:defRPr sz="1000" b="1">
+                        <a:defRPr sz="950" b="1">
                           <a:solidFill>
                             <a:srgbClr val="FFFFFF"/>
                           </a:solidFill>
@@ -3695,7 +3695,7 @@
                     <a:lstStyle/>
                     <a:p>
                       <a:pPr algn="ctr">
-                        <a:defRPr sz="1000" b="1">
+                        <a:defRPr sz="950" b="1">
                           <a:solidFill>
                             <a:srgbClr val="FFFFFF"/>
                           </a:solidFill>
@@ -3719,7 +3719,7 @@
                     <a:lstStyle/>
                     <a:p>
                       <a:pPr algn="ctr">
-                        <a:defRPr sz="1000" b="1">
+                        <a:defRPr sz="950" b="1">
                           <a:solidFill>
                             <a:srgbClr val="FFFFFF"/>
                           </a:solidFill>
@@ -3738,14 +3738,14 @@
                   </a:tcPr>
                 </a:tc>
               </a:tr>
-              <a:tr h="396240">
+              <a:tr h="411480">
                 <a:tc>
                   <a:txBody>
                     <a:bodyPr/>
                     <a:lstStyle/>
                     <a:p>
                       <a:pPr algn="l">
-                        <a:defRPr sz="1000" b="1">
+                        <a:defRPr sz="950" b="1">
                           <a:latin typeface="Calibri"/>
                         </a:defRPr>
                       </a:pPr>
@@ -3766,7 +3766,7 @@
                     <a:lstStyle/>
                     <a:p>
                       <a:pPr algn="ctr">
-                        <a:defRPr sz="1000" b="1">
+                        <a:defRPr sz="950" b="1">
                           <a:solidFill>
                             <a:srgbClr val="C2410C"/>
                           </a:solidFill>
@@ -3790,7 +3790,7 @@
                     <a:lstStyle/>
                     <a:p>
                       <a:pPr algn="ctr">
-                        <a:defRPr sz="1000">
+                        <a:defRPr sz="950">
                           <a:latin typeface="Calibri"/>
                         </a:defRPr>
                       </a:pPr>
@@ -3806,14 +3806,14 @@
                   </a:tcPr>
                 </a:tc>
               </a:tr>
-              <a:tr h="396240">
+              <a:tr h="411480">
                 <a:tc>
                   <a:txBody>
                     <a:bodyPr/>
                     <a:lstStyle/>
                     <a:p>
                       <a:pPr algn="l">
-                        <a:defRPr sz="1000" b="1">
+                        <a:defRPr sz="950" b="1">
                           <a:latin typeface="Calibri"/>
                         </a:defRPr>
                       </a:pPr>
@@ -3834,7 +3834,7 @@
                     <a:lstStyle/>
                     <a:p>
                       <a:pPr algn="ctr">
-                        <a:defRPr sz="1000" b="1">
+                        <a:defRPr sz="950" b="1">
                           <a:solidFill>
                             <a:srgbClr val="C2410C"/>
                           </a:solidFill>
@@ -3858,7 +3858,7 @@
                     <a:lstStyle/>
                     <a:p>
                       <a:pPr algn="ctr">
-                        <a:defRPr sz="1000">
+                        <a:defRPr sz="950">
                           <a:latin typeface="Calibri"/>
                         </a:defRPr>
                       </a:pPr>
@@ -3874,14 +3874,14 @@
                   </a:tcPr>
                 </a:tc>
               </a:tr>
-              <a:tr h="396240">
+              <a:tr h="411480">
                 <a:tc>
                   <a:txBody>
                     <a:bodyPr/>
                     <a:lstStyle/>
                     <a:p>
                       <a:pPr algn="l">
-                        <a:defRPr sz="1000" b="1">
+                        <a:defRPr sz="950" b="1">
                           <a:latin typeface="Calibri"/>
                         </a:defRPr>
                       </a:pPr>
@@ -3902,7 +3902,7 @@
                     <a:lstStyle/>
                     <a:p>
                       <a:pPr algn="ctr">
-                        <a:defRPr sz="1000" b="1">
+                        <a:defRPr sz="950" b="1">
                           <a:solidFill>
                             <a:srgbClr val="C2410C"/>
                           </a:solidFill>
@@ -3926,7 +3926,7 @@
                     <a:lstStyle/>
                     <a:p>
                       <a:pPr algn="ctr">
-                        <a:defRPr sz="1000">
+                        <a:defRPr sz="950">
                           <a:latin typeface="Calibri"/>
                         </a:defRPr>
                       </a:pPr>
@@ -3942,14 +3942,14 @@
                   </a:tcPr>
                 </a:tc>
               </a:tr>
-              <a:tr h="396240">
+              <a:tr h="411480">
                 <a:tc>
                   <a:txBody>
                     <a:bodyPr/>
                     <a:lstStyle/>
                     <a:p>
                       <a:pPr algn="l">
-                        <a:defRPr sz="1000" b="1">
+                        <a:defRPr sz="950" b="1">
                           <a:latin typeface="Calibri"/>
                         </a:defRPr>
                       </a:pPr>
@@ -3970,7 +3970,7 @@
                     <a:lstStyle/>
                     <a:p>
                       <a:pPr algn="ctr">
-                        <a:defRPr sz="1000" b="1">
+                        <a:defRPr sz="950" b="1">
                           <a:solidFill>
                             <a:srgbClr val="C2410C"/>
                           </a:solidFill>
@@ -3994,7 +3994,7 @@
                     <a:lstStyle/>
                     <a:p>
                       <a:pPr algn="ctr">
-                        <a:defRPr sz="1000">
+                        <a:defRPr sz="950">
                           <a:latin typeface="Calibri"/>
                         </a:defRPr>
                       </a:pPr>
@@ -4010,14 +4010,14 @@
                   </a:tcPr>
                 </a:tc>
               </a:tr>
-              <a:tr h="396240">
+              <a:tr h="411480">
                 <a:tc>
                   <a:txBody>
                     <a:bodyPr/>
                     <a:lstStyle/>
                     <a:p>
                       <a:pPr algn="l">
-                        <a:defRPr sz="1000" b="1">
+                        <a:defRPr sz="950" b="1">
                           <a:latin typeface="Calibri"/>
                         </a:defRPr>
                       </a:pPr>
@@ -4038,7 +4038,7 @@
                     <a:lstStyle/>
                     <a:p>
                       <a:pPr algn="ctr">
-                        <a:defRPr sz="1000" b="1">
+                        <a:defRPr sz="950" b="1">
                           <a:solidFill>
                             <a:srgbClr val="C2410C"/>
                           </a:solidFill>
@@ -4062,7 +4062,7 @@
                     <a:lstStyle/>
                     <a:p>
                       <a:pPr algn="ctr">
-                        <a:defRPr sz="1000">
+                        <a:defRPr sz="950">
                           <a:latin typeface="Calibri"/>
                         </a:defRPr>
                       </a:pPr>
@@ -4152,7 +4152,7 @@
         <p:spPr>
           <a:xfrm>
             <a:off x="0" y="0"/>
-            <a:ext cx="12191695" cy="1051560"/>
+            <a:ext cx="12191695" cy="1005840"/>
           </a:xfrm>
           <a:prstGeom prst="rect">
             <a:avLst/>
@@ -4194,8 +4194,8 @@
         </p:nvSpPr>
         <p:spPr>
           <a:xfrm>
-            <a:off x="0" y="1051560"/>
-            <a:ext cx="12191695" cy="54864"/>
+            <a:off x="0" y="1005840"/>
+            <a:ext cx="12191695" cy="45720"/>
           </a:xfrm>
           <a:prstGeom prst="rect">
             <a:avLst/>
@@ -4237,7 +4237,7 @@
         </p:nvSpPr>
         <p:spPr>
           <a:xfrm>
-            <a:off x="731520" y="109728"/>
+            <a:off x="731520" y="73152"/>
             <a:ext cx="10789920" cy="868680"/>
           </a:xfrm>
           <a:prstGeom prst="rect">
@@ -4252,7 +4252,7 @@
           <a:lstStyle/>
           <a:p>
             <a:pPr>
-              <a:defRPr sz="2300" b="1">
+              <a:defRPr sz="2200" b="1">
                 <a:solidFill>
                   <a:srgbClr val="FFFFFF"/>
                 </a:solidFill>
@@ -4265,7 +4265,7 @@
           </a:p>
           <a:p>
             <a:pPr>
-              <a:defRPr sz="1150">
+              <a:defRPr sz="1100">
                 <a:solidFill>
                   <a:srgbClr val="BFDBFE"/>
                 </a:solidFill>
@@ -4286,8 +4286,8 @@
         </p:nvSpPr>
         <p:spPr>
           <a:xfrm>
-            <a:off x="548640" y="1234440"/>
-            <a:ext cx="11094415" cy="2926080"/>
+            <a:off x="548640" y="1143000"/>
+            <a:ext cx="11094415" cy="2487168"/>
           </a:xfrm>
           <a:prstGeom prst="rect">
             <a:avLst/>
@@ -4295,7 +4295,7 @@
           <a:solidFill>
             <a:srgbClr val="FFFFFF"/>
           </a:solidFill>
-          <a:ln w="15240">
+          <a:ln w="13970">
             <a:solidFill>
               <a:srgbClr val="CBD5E1"/>
             </a:solidFill>
@@ -4331,8 +4331,8 @@
         </p:nvSpPr>
         <p:spPr>
           <a:xfrm>
-            <a:off x="731520" y="1325880"/>
-            <a:ext cx="10698480" cy="320040"/>
+            <a:off x="731520" y="1207008"/>
+            <a:ext cx="10698480" cy="274320"/>
           </a:xfrm>
           <a:prstGeom prst="rect">
             <a:avLst/>
@@ -4346,7 +4346,7 @@
           <a:lstStyle/>
           <a:p>
             <a:pPr>
-              <a:defRPr sz="1500" b="1">
+              <a:defRPr sz="1350" b="1">
                 <a:solidFill>
                   <a:srgbClr val="1E3A8A"/>
                 </a:solidFill>
@@ -4368,8 +4368,8 @@
           <p:nvPr/>
         </p:nvGraphicFramePr>
         <p:xfrm>
-          <a:off x="731520" y="1691640"/>
-          <a:ext cx="10835640" cy="2286000"/>
+          <a:off x="731520" y="1536192"/>
+          <a:ext cx="10725912" cy="1965960"/>
         </p:xfrm>
         <a:graphic>
           <a:graphicData uri="http://schemas.openxmlformats.org/drawingml/2006/table">
@@ -4378,25 +4378,25 @@
                 <a:tableStyleId>{5C22544A-7EE6-4342-B048-85BDC9FD1C3A}</a:tableStyleId>
               </a:tblPr>
               <a:tblGrid>
-                <a:gridCol w="2103120"/>
+                <a:gridCol w="2286000"/>
+                <a:gridCol w="868680"/>
+                <a:gridCol w="868680"/>
+                <a:gridCol w="868680"/>
+                <a:gridCol w="868680"/>
+                <a:gridCol w="777240"/>
                 <a:gridCol w="960120"/>
-                <a:gridCol w="960120"/>
-                <a:gridCol w="960120"/>
-                <a:gridCol w="960120"/>
-                <a:gridCol w="868680"/>
-                <a:gridCol w="1005840"/>
-                <a:gridCol w="1280160"/>
-                <a:gridCol w="1097280"/>
-                <a:gridCol w="640080"/>
+                <a:gridCol w="1143000"/>
+                <a:gridCol w="1188720"/>
+                <a:gridCol w="896112"/>
               </a:tblGrid>
-              <a:tr h="457200">
+              <a:tr h="393192">
                 <a:tc>
                   <a:txBody>
                     <a:bodyPr/>
                     <a:lstStyle/>
                     <a:p>
                       <a:pPr algn="ctr">
-                        <a:defRPr sz="1050" b="1">
+                        <a:defRPr sz="950" b="1">
                           <a:solidFill>
                             <a:srgbClr val="FFFFFF"/>
                           </a:solidFill>
@@ -4408,7 +4408,7 @@
                       </a:r>
                     </a:p>
                   </a:txBody>
-                  <a:tcPr>
+                  <a:tcPr marL="36576" marR="36576" marT="27432" marB="27432">
                     <a:solidFill>
                       <a:srgbClr val="1E3A8A"/>
                     </a:solidFill>
@@ -4420,7 +4420,7 @@
                     <a:lstStyle/>
                     <a:p>
                       <a:pPr algn="ctr">
-                        <a:defRPr sz="1050" b="1">
+                        <a:defRPr sz="950" b="1">
                           <a:solidFill>
                             <a:srgbClr val="FFFFFF"/>
                           </a:solidFill>
@@ -4432,7 +4432,7 @@
                       </a:r>
                     </a:p>
                   </a:txBody>
-                  <a:tcPr>
+                  <a:tcPr marL="36576" marR="36576" marT="27432" marB="27432">
                     <a:solidFill>
                       <a:srgbClr val="1E3A8A"/>
                     </a:solidFill>
@@ -4444,7 +4444,7 @@
                     <a:lstStyle/>
                     <a:p>
                       <a:pPr algn="ctr">
-                        <a:defRPr sz="1050" b="1">
+                        <a:defRPr sz="950" b="1">
                           <a:solidFill>
                             <a:srgbClr val="FFFFFF"/>
                           </a:solidFill>
@@ -4456,7 +4456,7 @@
                       </a:r>
                     </a:p>
                   </a:txBody>
-                  <a:tcPr>
+                  <a:tcPr marL="36576" marR="36576" marT="27432" marB="27432">
                     <a:solidFill>
                       <a:srgbClr val="1E3A8A"/>
                     </a:solidFill>
@@ -4468,7 +4468,7 @@
                     <a:lstStyle/>
                     <a:p>
                       <a:pPr algn="ctr">
-                        <a:defRPr sz="1050" b="1">
+                        <a:defRPr sz="950" b="1">
                           <a:solidFill>
                             <a:srgbClr val="FFFFFF"/>
                           </a:solidFill>
@@ -4480,7 +4480,7 @@
                       </a:r>
                     </a:p>
                   </a:txBody>
-                  <a:tcPr>
+                  <a:tcPr marL="36576" marR="36576" marT="27432" marB="27432">
                     <a:solidFill>
                       <a:srgbClr val="1E3A8A"/>
                     </a:solidFill>
@@ -4492,7 +4492,7 @@
                     <a:lstStyle/>
                     <a:p>
                       <a:pPr algn="ctr">
-                        <a:defRPr sz="1050" b="1">
+                        <a:defRPr sz="950" b="1">
                           <a:solidFill>
                             <a:srgbClr val="FFFFFF"/>
                           </a:solidFill>
@@ -4504,7 +4504,7 @@
                       </a:r>
                     </a:p>
                   </a:txBody>
-                  <a:tcPr>
+                  <a:tcPr marL="36576" marR="36576" marT="27432" marB="27432">
                     <a:solidFill>
                       <a:srgbClr val="1E3A8A"/>
                     </a:solidFill>
@@ -4516,7 +4516,7 @@
                     <a:lstStyle/>
                     <a:p>
                       <a:pPr algn="ctr">
-                        <a:defRPr sz="1050" b="1">
+                        <a:defRPr sz="950" b="1">
                           <a:solidFill>
                             <a:srgbClr val="FFFFFF"/>
                           </a:solidFill>
@@ -4528,7 +4528,7 @@
                       </a:r>
                     </a:p>
                   </a:txBody>
-                  <a:tcPr>
+                  <a:tcPr marL="36576" marR="36576" marT="27432" marB="27432">
                     <a:solidFill>
                       <a:srgbClr val="1E3A8A"/>
                     </a:solidFill>
@@ -4540,7 +4540,7 @@
                     <a:lstStyle/>
                     <a:p>
                       <a:pPr algn="ctr">
-                        <a:defRPr sz="1050" b="1">
+                        <a:defRPr sz="950" b="1">
                           <a:solidFill>
                             <a:srgbClr val="FFFFFF"/>
                           </a:solidFill>
@@ -4552,7 +4552,7 @@
                       </a:r>
                     </a:p>
                   </a:txBody>
-                  <a:tcPr>
+                  <a:tcPr marL="36576" marR="36576" marT="27432" marB="27432">
                     <a:solidFill>
                       <a:srgbClr val="1E3A8A"/>
                     </a:solidFill>
@@ -4564,7 +4564,7 @@
                     <a:lstStyle/>
                     <a:p>
                       <a:pPr algn="ctr">
-                        <a:defRPr sz="1050" b="1">
+                        <a:defRPr sz="950" b="1">
                           <a:solidFill>
                             <a:srgbClr val="FFFFFF"/>
                           </a:solidFill>
@@ -4572,11 +4572,16 @@
                         </a:defRPr>
                       </a:pPr>
                       <a:r>
-                        <a:t>Inference Time (175k flows)</a:t>
+                        <a:t>Inference Time</a:t>
+                      </a:r>
+                    </a:p>
+                    <a:p>
+                      <a:r>
+                        <a:t>(175k flows)</a:t>
                       </a:r>
                     </a:p>
                   </a:txBody>
-                  <a:tcPr>
+                  <a:tcPr marL="36576" marR="36576" marT="27432" marB="27432">
                     <a:solidFill>
                       <a:srgbClr val="1E3A8A"/>
                     </a:solidFill>
@@ -4588,7 +4593,7 @@
                     <a:lstStyle/>
                     <a:p>
                       <a:pPr algn="ctr">
-                        <a:defRPr sz="1050" b="1">
+                        <a:defRPr sz="950" b="1">
                           <a:solidFill>
                             <a:srgbClr val="FFFFFF"/>
                           </a:solidFill>
@@ -4596,11 +4601,16 @@
                         </a:defRPr>
                       </a:pPr>
                       <a:r>
-                        <a:t>Per-Sample Latency</a:t>
+                        <a:t>Per-Sample</a:t>
+                      </a:r>
+                    </a:p>
+                    <a:p>
+                      <a:r>
+                        <a:t>Latency</a:t>
                       </a:r>
                     </a:p>
                   </a:txBody>
-                  <a:tcPr>
+                  <a:tcPr marL="36576" marR="36576" marT="27432" marB="27432">
                     <a:solidFill>
                       <a:srgbClr val="1E3A8A"/>
                     </a:solidFill>
@@ -4612,7 +4622,7 @@
                     <a:lstStyle/>
                     <a:p>
                       <a:pPr algn="ctr">
-                        <a:defRPr sz="1050" b="1">
+                        <a:defRPr sz="950" b="1">
                           <a:solidFill>
                             <a:srgbClr val="FFFFFF"/>
                           </a:solidFill>
@@ -4624,21 +4634,21 @@
                       </a:r>
                     </a:p>
                   </a:txBody>
-                  <a:tcPr>
+                  <a:tcPr marL="36576" marR="36576" marT="27432" marB="27432">
                     <a:solidFill>
                       <a:srgbClr val="1E3A8A"/>
                     </a:solidFill>
                   </a:tcPr>
                 </a:tc>
               </a:tr>
-              <a:tr h="457200">
+              <a:tr h="393192">
                 <a:tc>
                   <a:txBody>
                     <a:bodyPr/>
                     <a:lstStyle/>
                     <a:p>
-                      <a:pPr algn="ctr">
-                        <a:defRPr sz="1000" b="1">
+                      <a:pPr algn="l">
+                        <a:defRPr sz="950" b="1">
                           <a:solidFill>
                             <a:srgbClr val="15803D"/>
                           </a:solidFill>
@@ -4646,16 +4656,11 @@
                         </a:defRPr>
                       </a:pPr>
                       <a:r>
-                        <a:t>Proposed Model</a:t>
-                      </a:r>
-                    </a:p>
-                    <a:p>
-                      <a:r>
-                        <a:t>(Lightweight Ensemble)</a:t>
+                        <a:t>Proposed Model (Lightweight Ensemble)</a:t>
                       </a:r>
                     </a:p>
                   </a:txBody>
-                  <a:tcPr>
+                  <a:tcPr marL="36576" marR="36576" marT="27432" marB="27432">
                     <a:solidFill>
                       <a:srgbClr val="ECFDF5"/>
                     </a:solidFill>
@@ -4667,7 +4672,7 @@
                     <a:lstStyle/>
                     <a:p>
                       <a:pPr algn="ctr">
-                        <a:defRPr sz="1000" b="1">
+                        <a:defRPr sz="950" b="1">
                           <a:solidFill>
                             <a:srgbClr val="15803D"/>
                           </a:solidFill>
@@ -4679,7 +4684,7 @@
                       </a:r>
                     </a:p>
                   </a:txBody>
-                  <a:tcPr>
+                  <a:tcPr marL="36576" marR="36576" marT="27432" marB="27432">
                     <a:solidFill>
                       <a:srgbClr val="ECFDF5"/>
                     </a:solidFill>
@@ -4691,7 +4696,7 @@
                     <a:lstStyle/>
                     <a:p>
                       <a:pPr algn="ctr">
-                        <a:defRPr sz="1000">
+                        <a:defRPr sz="950">
                           <a:latin typeface="Calibri"/>
                         </a:defRPr>
                       </a:pPr>
@@ -4700,7 +4705,7 @@
                       </a:r>
                     </a:p>
                   </a:txBody>
-                  <a:tcPr>
+                  <a:tcPr marL="36576" marR="36576" marT="27432" marB="27432">
                     <a:solidFill>
                       <a:srgbClr val="ECFDF5"/>
                     </a:solidFill>
@@ -4712,7 +4717,7 @@
                     <a:lstStyle/>
                     <a:p>
                       <a:pPr algn="ctr">
-                        <a:defRPr sz="1000">
+                        <a:defRPr sz="950">
                           <a:latin typeface="Calibri"/>
                         </a:defRPr>
                       </a:pPr>
@@ -4721,7 +4726,7 @@
                       </a:r>
                     </a:p>
                   </a:txBody>
-                  <a:tcPr>
+                  <a:tcPr marL="36576" marR="36576" marT="27432" marB="27432">
                     <a:solidFill>
                       <a:srgbClr val="ECFDF5"/>
                     </a:solidFill>
@@ -4733,7 +4738,7 @@
                     <a:lstStyle/>
                     <a:p>
                       <a:pPr algn="ctr">
-                        <a:defRPr sz="1000" b="1">
+                        <a:defRPr sz="950" b="1">
                           <a:solidFill>
                             <a:srgbClr val="15803D"/>
                           </a:solidFill>
@@ -4745,7 +4750,7 @@
                       </a:r>
                     </a:p>
                   </a:txBody>
-                  <a:tcPr>
+                  <a:tcPr marL="36576" marR="36576" marT="27432" marB="27432">
                     <a:solidFill>
                       <a:srgbClr val="ECFDF5"/>
                     </a:solidFill>
@@ -4757,7 +4762,7 @@
                     <a:lstStyle/>
                     <a:p>
                       <a:pPr algn="ctr">
-                        <a:defRPr sz="1000">
+                        <a:defRPr sz="950">
                           <a:latin typeface="Calibri"/>
                         </a:defRPr>
                       </a:pPr>
@@ -4766,7 +4771,7 @@
                       </a:r>
                     </a:p>
                   </a:txBody>
-                  <a:tcPr>
+                  <a:tcPr marL="36576" marR="36576" marT="27432" marB="27432">
                     <a:solidFill>
                       <a:srgbClr val="ECFDF5"/>
                     </a:solidFill>
@@ -4778,7 +4783,7 @@
                     <a:lstStyle/>
                     <a:p>
                       <a:pPr algn="ctr">
-                        <a:defRPr sz="1000">
+                        <a:defRPr sz="950">
                           <a:latin typeface="Calibri"/>
                         </a:defRPr>
                       </a:pPr>
@@ -4787,7 +4792,7 @@
                       </a:r>
                     </a:p>
                   </a:txBody>
-                  <a:tcPr>
+                  <a:tcPr marL="36576" marR="36576" marT="27432" marB="27432">
                     <a:solidFill>
                       <a:srgbClr val="ECFDF5"/>
                     </a:solidFill>
@@ -4799,7 +4804,7 @@
                     <a:lstStyle/>
                     <a:p>
                       <a:pPr algn="ctr">
-                        <a:defRPr sz="1000">
+                        <a:defRPr sz="950">
                           <a:latin typeface="Calibri"/>
                         </a:defRPr>
                       </a:pPr>
@@ -4808,7 +4813,7 @@
                       </a:r>
                     </a:p>
                   </a:txBody>
-                  <a:tcPr>
+                  <a:tcPr marL="36576" marR="36576" marT="27432" marB="27432">
                     <a:solidFill>
                       <a:srgbClr val="ECFDF5"/>
                     </a:solidFill>
@@ -4820,7 +4825,7 @@
                     <a:lstStyle/>
                     <a:p>
                       <a:pPr algn="ctr">
-                        <a:defRPr sz="1000">
+                        <a:defRPr sz="950">
                           <a:latin typeface="Calibri"/>
                         </a:defRPr>
                       </a:pPr>
@@ -4829,7 +4834,7 @@
                       </a:r>
                     </a:p>
                   </a:txBody>
-                  <a:tcPr>
+                  <a:tcPr marL="36576" marR="36576" marT="27432" marB="27432">
                     <a:solidFill>
                       <a:srgbClr val="ECFDF5"/>
                     </a:solidFill>
@@ -4841,7 +4846,7 @@
                     <a:lstStyle/>
                     <a:p>
                       <a:pPr algn="ctr">
-                        <a:defRPr sz="1000">
+                        <a:defRPr sz="950">
                           <a:latin typeface="Calibri"/>
                         </a:defRPr>
                       </a:pPr>
@@ -4850,21 +4855,21 @@
                       </a:r>
                     </a:p>
                   </a:txBody>
-                  <a:tcPr>
+                  <a:tcPr marL="36576" marR="36576" marT="27432" marB="27432">
                     <a:solidFill>
                       <a:srgbClr val="ECFDF5"/>
                     </a:solidFill>
                   </a:tcPr>
                 </a:tc>
               </a:tr>
-              <a:tr h="457200">
+              <a:tr h="393192">
                 <a:tc>
                   <a:txBody>
                     <a:bodyPr/>
                     <a:lstStyle/>
                     <a:p>
-                      <a:pPr algn="ctr">
-                        <a:defRPr sz="1000" b="1">
+                      <a:pPr algn="l">
+                        <a:defRPr sz="950" b="1">
                           <a:solidFill>
                             <a:srgbClr val="0F172A"/>
                           </a:solidFill>
@@ -4872,16 +4877,11 @@
                         </a:defRPr>
                       </a:pPr>
                       <a:r>
-                        <a:t>Rerun SVM</a:t>
-                      </a:r>
-                    </a:p>
-                    <a:p>
-                      <a:r>
-                        <a:t>(RBF Kernel)</a:t>
+                        <a:t>Rerun SVM (RBF Kernel)</a:t>
                       </a:r>
                     </a:p>
                   </a:txBody>
-                  <a:tcPr>
+                  <a:tcPr marL="36576" marR="36576" marT="27432" marB="27432">
                     <a:solidFill>
                       <a:srgbClr val="F8FAFC"/>
                     </a:solidFill>
@@ -4893,7 +4893,7 @@
                     <a:lstStyle/>
                     <a:p>
                       <a:pPr algn="ctr">
-                        <a:defRPr sz="1000" b="1">
+                        <a:defRPr sz="950" b="1">
                           <a:solidFill>
                             <a:srgbClr val="2563EB"/>
                           </a:solidFill>
@@ -4905,7 +4905,7 @@
                       </a:r>
                     </a:p>
                   </a:txBody>
-                  <a:tcPr>
+                  <a:tcPr marL="36576" marR="36576" marT="27432" marB="27432">
                     <a:solidFill>
                       <a:srgbClr val="F8FAFC"/>
                     </a:solidFill>
@@ -4917,7 +4917,7 @@
                     <a:lstStyle/>
                     <a:p>
                       <a:pPr algn="ctr">
-                        <a:defRPr sz="1000">
+                        <a:defRPr sz="950">
                           <a:latin typeface="Calibri"/>
                         </a:defRPr>
                       </a:pPr>
@@ -4926,7 +4926,7 @@
                       </a:r>
                     </a:p>
                   </a:txBody>
-                  <a:tcPr>
+                  <a:tcPr marL="36576" marR="36576" marT="27432" marB="27432">
                     <a:solidFill>
                       <a:srgbClr val="F8FAFC"/>
                     </a:solidFill>
@@ -4938,7 +4938,7 @@
                     <a:lstStyle/>
                     <a:p>
                       <a:pPr algn="ctr">
-                        <a:defRPr sz="1000">
+                        <a:defRPr sz="950">
                           <a:latin typeface="Calibri"/>
                         </a:defRPr>
                       </a:pPr>
@@ -4947,7 +4947,7 @@
                       </a:r>
                     </a:p>
                   </a:txBody>
-                  <a:tcPr>
+                  <a:tcPr marL="36576" marR="36576" marT="27432" marB="27432">
                     <a:solidFill>
                       <a:srgbClr val="F8FAFC"/>
                     </a:solidFill>
@@ -4959,7 +4959,7 @@
                     <a:lstStyle/>
                     <a:p>
                       <a:pPr algn="ctr">
-                        <a:defRPr sz="1000" b="1">
+                        <a:defRPr sz="950" b="1">
                           <a:solidFill>
                             <a:srgbClr val="2563EB"/>
                           </a:solidFill>
@@ -4971,7 +4971,7 @@
                       </a:r>
                     </a:p>
                   </a:txBody>
-                  <a:tcPr>
+                  <a:tcPr marL="36576" marR="36576" marT="27432" marB="27432">
                     <a:solidFill>
                       <a:srgbClr val="F8FAFC"/>
                     </a:solidFill>
@@ -4983,7 +4983,7 @@
                     <a:lstStyle/>
                     <a:p>
                       <a:pPr algn="ctr">
-                        <a:defRPr sz="1000">
+                        <a:defRPr sz="950">
                           <a:latin typeface="Calibri"/>
                         </a:defRPr>
                       </a:pPr>
@@ -4992,7 +4992,7 @@
                       </a:r>
                     </a:p>
                   </a:txBody>
-                  <a:tcPr>
+                  <a:tcPr marL="36576" marR="36576" marT="27432" marB="27432">
                     <a:solidFill>
                       <a:srgbClr val="F8FAFC"/>
                     </a:solidFill>
@@ -5004,7 +5004,7 @@
                     <a:lstStyle/>
                     <a:p>
                       <a:pPr algn="ctr">
-                        <a:defRPr sz="1000">
+                        <a:defRPr sz="950">
                           <a:latin typeface="Calibri"/>
                         </a:defRPr>
                       </a:pPr>
@@ -5013,7 +5013,7 @@
                       </a:r>
                     </a:p>
                   </a:txBody>
-                  <a:tcPr>
+                  <a:tcPr marL="36576" marR="36576" marT="27432" marB="27432">
                     <a:solidFill>
                       <a:srgbClr val="F8FAFC"/>
                     </a:solidFill>
@@ -5025,7 +5025,7 @@
                     <a:lstStyle/>
                     <a:p>
                       <a:pPr algn="ctr">
-                        <a:defRPr sz="1000">
+                        <a:defRPr sz="950">
                           <a:latin typeface="Calibri"/>
                         </a:defRPr>
                       </a:pPr>
@@ -5034,7 +5034,7 @@
                       </a:r>
                     </a:p>
                   </a:txBody>
-                  <a:tcPr>
+                  <a:tcPr marL="36576" marR="36576" marT="27432" marB="27432">
                     <a:solidFill>
                       <a:srgbClr val="F8FAFC"/>
                     </a:solidFill>
@@ -5046,7 +5046,7 @@
                     <a:lstStyle/>
                     <a:p>
                       <a:pPr algn="ctr">
-                        <a:defRPr sz="1000">
+                        <a:defRPr sz="950">
                           <a:latin typeface="Calibri"/>
                         </a:defRPr>
                       </a:pPr>
@@ -5055,7 +5055,7 @@
                       </a:r>
                     </a:p>
                   </a:txBody>
-                  <a:tcPr>
+                  <a:tcPr marL="36576" marR="36576" marT="27432" marB="27432">
                     <a:solidFill>
                       <a:srgbClr val="F8FAFC"/>
                     </a:solidFill>
@@ -5067,7 +5067,7 @@
                     <a:lstStyle/>
                     <a:p>
                       <a:pPr algn="ctr">
-                        <a:defRPr sz="1000">
+                        <a:defRPr sz="950">
                           <a:latin typeface="Calibri"/>
                         </a:defRPr>
                       </a:pPr>
@@ -5076,21 +5076,21 @@
                       </a:r>
                     </a:p>
                   </a:txBody>
-                  <a:tcPr>
+                  <a:tcPr marL="36576" marR="36576" marT="27432" marB="27432">
                     <a:solidFill>
                       <a:srgbClr val="F8FAFC"/>
                     </a:solidFill>
                   </a:tcPr>
                 </a:tc>
               </a:tr>
-              <a:tr h="457200">
+              <a:tr h="393192">
                 <a:tc>
                   <a:txBody>
                     <a:bodyPr/>
                     <a:lstStyle/>
                     <a:p>
-                      <a:pPr algn="ctr">
-                        <a:defRPr sz="1000" b="1">
+                      <a:pPr algn="l">
+                        <a:defRPr sz="950" b="1">
                           <a:solidFill>
                             <a:srgbClr val="0F172A"/>
                           </a:solidFill>
@@ -5098,16 +5098,11 @@
                         </a:defRPr>
                       </a:pPr>
                       <a:r>
-                        <a:t>Rerun CNN+SVM</a:t>
-                      </a:r>
-                    </a:p>
-                    <a:p>
-                      <a:r>
-                        <a:t>(Hybrid)</a:t>
+                        <a:t>Rerun CNN+SVM (Hybrid)</a:t>
                       </a:r>
                     </a:p>
                   </a:txBody>
-                  <a:tcPr>
+                  <a:tcPr marL="36576" marR="36576" marT="27432" marB="27432">
                     <a:solidFill>
                       <a:srgbClr val="FFFFFF"/>
                     </a:solidFill>
@@ -5119,7 +5114,7 @@
                     <a:lstStyle/>
                     <a:p>
                       <a:pPr algn="ctr">
-                        <a:defRPr sz="1000" b="1">
+                        <a:defRPr sz="950" b="1">
                           <a:solidFill>
                             <a:srgbClr val="2563EB"/>
                           </a:solidFill>
@@ -5131,7 +5126,7 @@
                       </a:r>
                     </a:p>
                   </a:txBody>
-                  <a:tcPr>
+                  <a:tcPr marL="36576" marR="36576" marT="27432" marB="27432">
                     <a:solidFill>
                       <a:srgbClr val="FFFFFF"/>
                     </a:solidFill>
@@ -5143,7 +5138,7 @@
                     <a:lstStyle/>
                     <a:p>
                       <a:pPr algn="ctr">
-                        <a:defRPr sz="1000">
+                        <a:defRPr sz="950">
                           <a:latin typeface="Calibri"/>
                         </a:defRPr>
                       </a:pPr>
@@ -5152,7 +5147,7 @@
                       </a:r>
                     </a:p>
                   </a:txBody>
-                  <a:tcPr>
+                  <a:tcPr marL="36576" marR="36576" marT="27432" marB="27432">
                     <a:solidFill>
                       <a:srgbClr val="FFFFFF"/>
                     </a:solidFill>
@@ -5164,7 +5159,7 @@
                     <a:lstStyle/>
                     <a:p>
                       <a:pPr algn="ctr">
-                        <a:defRPr sz="1000">
+                        <a:defRPr sz="950">
                           <a:latin typeface="Calibri"/>
                         </a:defRPr>
                       </a:pPr>
@@ -5173,7 +5168,7 @@
                       </a:r>
                     </a:p>
                   </a:txBody>
-                  <a:tcPr>
+                  <a:tcPr marL="36576" marR="36576" marT="27432" marB="27432">
                     <a:solidFill>
                       <a:srgbClr val="FFFFFF"/>
                     </a:solidFill>
@@ -5185,7 +5180,7 @@
                     <a:lstStyle/>
                     <a:p>
                       <a:pPr algn="ctr">
-                        <a:defRPr sz="1000" b="1">
+                        <a:defRPr sz="950" b="1">
                           <a:solidFill>
                             <a:srgbClr val="2563EB"/>
                           </a:solidFill>
@@ -5197,7 +5192,7 @@
                       </a:r>
                     </a:p>
                   </a:txBody>
-                  <a:tcPr>
+                  <a:tcPr marL="36576" marR="36576" marT="27432" marB="27432">
                     <a:solidFill>
                       <a:srgbClr val="FFFFFF"/>
                     </a:solidFill>
@@ -5209,7 +5204,7 @@
                     <a:lstStyle/>
                     <a:p>
                       <a:pPr algn="ctr">
-                        <a:defRPr sz="1000">
+                        <a:defRPr sz="950">
                           <a:latin typeface="Calibri"/>
                         </a:defRPr>
                       </a:pPr>
@@ -5218,7 +5213,7 @@
                       </a:r>
                     </a:p>
                   </a:txBody>
-                  <a:tcPr>
+                  <a:tcPr marL="36576" marR="36576" marT="27432" marB="27432">
                     <a:solidFill>
                       <a:srgbClr val="FFFFFF"/>
                     </a:solidFill>
@@ -5230,7 +5225,7 @@
                     <a:lstStyle/>
                     <a:p>
                       <a:pPr algn="ctr">
-                        <a:defRPr sz="1000">
+                        <a:defRPr sz="950">
                           <a:latin typeface="Calibri"/>
                         </a:defRPr>
                       </a:pPr>
@@ -5239,7 +5234,7 @@
                       </a:r>
                     </a:p>
                   </a:txBody>
-                  <a:tcPr>
+                  <a:tcPr marL="36576" marR="36576" marT="27432" marB="27432">
                     <a:solidFill>
                       <a:srgbClr val="FFFFFF"/>
                     </a:solidFill>
@@ -5251,7 +5246,7 @@
                     <a:lstStyle/>
                     <a:p>
                       <a:pPr algn="ctr">
-                        <a:defRPr sz="1000">
+                        <a:defRPr sz="950">
                           <a:latin typeface="Calibri"/>
                         </a:defRPr>
                       </a:pPr>
@@ -5260,7 +5255,7 @@
                       </a:r>
                     </a:p>
                   </a:txBody>
-                  <a:tcPr>
+                  <a:tcPr marL="36576" marR="36576" marT="27432" marB="27432">
                     <a:solidFill>
                       <a:srgbClr val="FFFFFF"/>
                     </a:solidFill>
@@ -5272,7 +5267,7 @@
                     <a:lstStyle/>
                     <a:p>
                       <a:pPr algn="ctr">
-                        <a:defRPr sz="1000">
+                        <a:defRPr sz="950">
                           <a:latin typeface="Calibri"/>
                         </a:defRPr>
                       </a:pPr>
@@ -5281,7 +5276,7 @@
                       </a:r>
                     </a:p>
                   </a:txBody>
-                  <a:tcPr>
+                  <a:tcPr marL="36576" marR="36576" marT="27432" marB="27432">
                     <a:solidFill>
                       <a:srgbClr val="FFFFFF"/>
                     </a:solidFill>
@@ -5293,7 +5288,7 @@
                     <a:lstStyle/>
                     <a:p>
                       <a:pPr algn="ctr">
-                        <a:defRPr sz="1000">
+                        <a:defRPr sz="950">
                           <a:latin typeface="Calibri"/>
                         </a:defRPr>
                       </a:pPr>
@@ -5302,21 +5297,21 @@
                       </a:r>
                     </a:p>
                   </a:txBody>
-                  <a:tcPr>
+                  <a:tcPr marL="36576" marR="36576" marT="27432" marB="27432">
                     <a:solidFill>
                       <a:srgbClr val="FFFFFF"/>
                     </a:solidFill>
                   </a:tcPr>
                 </a:tc>
               </a:tr>
-              <a:tr h="457200">
+              <a:tr h="393192">
                 <a:tc>
                   <a:txBody>
                     <a:bodyPr/>
                     <a:lstStyle/>
                     <a:p>
-                      <a:pPr algn="ctr">
-                        <a:defRPr sz="1000" b="1">
+                      <a:pPr algn="l">
+                        <a:defRPr sz="950" b="1">
                           <a:solidFill>
                             <a:srgbClr val="0F172A"/>
                           </a:solidFill>
@@ -5324,16 +5319,11 @@
                         </a:defRPr>
                       </a:pPr>
                       <a:r>
-                        <a:t>Rerun CNN</a:t>
-                      </a:r>
-                    </a:p>
-                    <a:p>
-                      <a:r>
-                        <a:t>(MLP Feature Extractor)</a:t>
+                        <a:t>Rerun CNN (MLP Feature Extractor)</a:t>
                       </a:r>
                     </a:p>
                   </a:txBody>
-                  <a:tcPr>
+                  <a:tcPr marL="36576" marR="36576" marT="27432" marB="27432">
                     <a:solidFill>
                       <a:srgbClr val="F8FAFC"/>
                     </a:solidFill>
@@ -5345,7 +5335,7 @@
                     <a:lstStyle/>
                     <a:p>
                       <a:pPr algn="ctr">
-                        <a:defRPr sz="1000" b="1">
+                        <a:defRPr sz="950" b="1">
                           <a:solidFill>
                             <a:srgbClr val="2563EB"/>
                           </a:solidFill>
@@ -5357,7 +5347,7 @@
                       </a:r>
                     </a:p>
                   </a:txBody>
-                  <a:tcPr>
+                  <a:tcPr marL="36576" marR="36576" marT="27432" marB="27432">
                     <a:solidFill>
                       <a:srgbClr val="F8FAFC"/>
                     </a:solidFill>
@@ -5369,7 +5359,7 @@
                     <a:lstStyle/>
                     <a:p>
                       <a:pPr algn="ctr">
-                        <a:defRPr sz="1000">
+                        <a:defRPr sz="950">
                           <a:latin typeface="Calibri"/>
                         </a:defRPr>
                       </a:pPr>
@@ -5378,7 +5368,7 @@
                       </a:r>
                     </a:p>
                   </a:txBody>
-                  <a:tcPr>
+                  <a:tcPr marL="36576" marR="36576" marT="27432" marB="27432">
                     <a:solidFill>
                       <a:srgbClr val="F8FAFC"/>
                     </a:solidFill>
@@ -5390,7 +5380,7 @@
                     <a:lstStyle/>
                     <a:p>
                       <a:pPr algn="ctr">
-                        <a:defRPr sz="1000">
+                        <a:defRPr sz="950">
                           <a:latin typeface="Calibri"/>
                         </a:defRPr>
                       </a:pPr>
@@ -5399,7 +5389,7 @@
                       </a:r>
                     </a:p>
                   </a:txBody>
-                  <a:tcPr>
+                  <a:tcPr marL="36576" marR="36576" marT="27432" marB="27432">
                     <a:solidFill>
                       <a:srgbClr val="F8FAFC"/>
                     </a:solidFill>
@@ -5411,7 +5401,7 @@
                     <a:lstStyle/>
                     <a:p>
                       <a:pPr algn="ctr">
-                        <a:defRPr sz="1000" b="1">
+                        <a:defRPr sz="950" b="1">
                           <a:solidFill>
                             <a:srgbClr val="2563EB"/>
                           </a:solidFill>
@@ -5423,7 +5413,7 @@
                       </a:r>
                     </a:p>
                   </a:txBody>
-                  <a:tcPr>
+                  <a:tcPr marL="36576" marR="36576" marT="27432" marB="27432">
                     <a:solidFill>
                       <a:srgbClr val="F8FAFC"/>
                     </a:solidFill>
@@ -5435,7 +5425,7 @@
                     <a:lstStyle/>
                     <a:p>
                       <a:pPr algn="ctr">
-                        <a:defRPr sz="1000">
+                        <a:defRPr sz="950">
                           <a:latin typeface="Calibri"/>
                         </a:defRPr>
                       </a:pPr>
@@ -5444,7 +5434,7 @@
                       </a:r>
                     </a:p>
                   </a:txBody>
-                  <a:tcPr>
+                  <a:tcPr marL="36576" marR="36576" marT="27432" marB="27432">
                     <a:solidFill>
                       <a:srgbClr val="F8FAFC"/>
                     </a:solidFill>
@@ -5456,7 +5446,7 @@
                     <a:lstStyle/>
                     <a:p>
                       <a:pPr algn="ctr">
-                        <a:defRPr sz="1000">
+                        <a:defRPr sz="950">
                           <a:latin typeface="Calibri"/>
                         </a:defRPr>
                       </a:pPr>
@@ -5465,7 +5455,7 @@
                       </a:r>
                     </a:p>
                   </a:txBody>
-                  <a:tcPr>
+                  <a:tcPr marL="36576" marR="36576" marT="27432" marB="27432">
                     <a:solidFill>
                       <a:srgbClr val="F8FAFC"/>
                     </a:solidFill>
@@ -5477,7 +5467,7 @@
                     <a:lstStyle/>
                     <a:p>
                       <a:pPr algn="ctr">
-                        <a:defRPr sz="1000">
+                        <a:defRPr sz="950">
                           <a:latin typeface="Calibri"/>
                         </a:defRPr>
                       </a:pPr>
@@ -5486,7 +5476,7 @@
                       </a:r>
                     </a:p>
                   </a:txBody>
-                  <a:tcPr>
+                  <a:tcPr marL="36576" marR="36576" marT="27432" marB="27432">
                     <a:solidFill>
                       <a:srgbClr val="F8FAFC"/>
                     </a:solidFill>
@@ -5498,7 +5488,7 @@
                     <a:lstStyle/>
                     <a:p>
                       <a:pPr algn="ctr">
-                        <a:defRPr sz="1000">
+                        <a:defRPr sz="950">
                           <a:latin typeface="Calibri"/>
                         </a:defRPr>
                       </a:pPr>
@@ -5507,7 +5497,7 @@
                       </a:r>
                     </a:p>
                   </a:txBody>
-                  <a:tcPr>
+                  <a:tcPr marL="36576" marR="36576" marT="27432" marB="27432">
                     <a:solidFill>
                       <a:srgbClr val="F8FAFC"/>
                     </a:solidFill>
@@ -5519,7 +5509,7 @@
                     <a:lstStyle/>
                     <a:p>
                       <a:pPr algn="ctr">
-                        <a:defRPr sz="1000">
+                        <a:defRPr sz="950">
                           <a:latin typeface="Calibri"/>
                         </a:defRPr>
                       </a:pPr>
@@ -5528,7 +5518,7 @@
                       </a:r>
                     </a:p>
                   </a:txBody>
-                  <a:tcPr>
+                  <a:tcPr marL="36576" marR="36576" marT="27432" marB="27432">
                     <a:solidFill>
                       <a:srgbClr val="F8FAFC"/>
                     </a:solidFill>
@@ -5547,8 +5537,8 @@
         </p:nvSpPr>
         <p:spPr>
           <a:xfrm>
-            <a:off x="548640" y="4297680"/>
-            <a:ext cx="11094415" cy="2331720"/>
+            <a:off x="548640" y="3794760"/>
+            <a:ext cx="11094415" cy="2834640"/>
           </a:xfrm>
           <a:prstGeom prst="rect">
             <a:avLst/>
@@ -5556,7 +5546,7 @@
           <a:solidFill>
             <a:srgbClr val="FFFFFF"/>
           </a:solidFill>
-          <a:ln w="15240">
+          <a:ln w="13970">
             <a:solidFill>
               <a:srgbClr val="CBD5E1"/>
             </a:solidFill>
@@ -5592,7 +5582,7 @@
         </p:nvSpPr>
         <p:spPr>
           <a:xfrm>
-            <a:off x="731520" y="4370832"/>
+            <a:off x="731520" y="3886200"/>
             <a:ext cx="10698480" cy="320040"/>
           </a:xfrm>
           <a:prstGeom prst="rect">
@@ -5607,7 +5597,7 @@
           <a:lstStyle/>
           <a:p>
             <a:pPr>
-              <a:defRPr sz="1400" b="1">
+              <a:defRPr sz="1350" b="1">
                 <a:solidFill>
                   <a:srgbClr val="1E3A8A"/>
                 </a:solidFill>
@@ -5628,8 +5618,8 @@
         </p:nvSpPr>
         <p:spPr>
           <a:xfrm>
-            <a:off x="731520" y="4681728"/>
-            <a:ext cx="10698480" cy="1828800"/>
+            <a:off x="731520" y="4251960"/>
+            <a:ext cx="10698480" cy="2286000"/>
           </a:xfrm>
           <a:prstGeom prst="rect">
             <a:avLst/>
@@ -5643,7 +5633,7 @@
           <a:lstStyle/>
           <a:p>
             <a:pPr>
-              <a:defRPr sz="1100" b="1">
+              <a:defRPr sz="1050" b="1">
                 <a:solidFill>
                   <a:srgbClr val="15803D"/>
                 </a:solidFill>
@@ -5654,7 +5644,7 @@
               <a:t>✔ Target Accuracy Benchmark Exceeded (&gt;90%): </a:t>
             </a:r>
             <a:r>
-              <a:rPr sz="1050" b="0">
+              <a:rPr sz="1000" b="0">
                 <a:solidFill>
                   <a:srgbClr val="1E293B"/>
                 </a:solidFill>
@@ -5665,7 +5655,7 @@
           </a:p>
           <a:p>
             <a:pPr>
-              <a:defRPr sz="1100" b="1">
+              <a:defRPr sz="1050" b="1">
                 <a:solidFill>
                   <a:srgbClr val="15803D"/>
                 </a:solidFill>
@@ -5676,7 +5666,7 @@
               <a:t>✔ Sub-Microsecond Wire-Speed Inference: </a:t>
             </a:r>
             <a:r>
-              <a:rPr sz="1050" b="0">
+              <a:rPr sz="1000" b="0">
                 <a:solidFill>
                   <a:srgbClr val="1E293B"/>
                 </a:solidFill>
@@ -5687,7 +5677,7 @@
           </a:p>
           <a:p>
             <a:pPr>
-              <a:defRPr sz="1100" b="1">
+              <a:defRPr sz="1050" b="1">
                 <a:solidFill>
                   <a:srgbClr val="15803D"/>
                 </a:solidFill>
@@ -5698,7 +5688,7 @@
               <a:t>✔ Lowest False Alarm Rate (FPR = 2.51%): </a:t>
             </a:r>
             <a:r>
-              <a:rPr sz="1050" b="0">
+              <a:rPr sz="1000" b="0">
                 <a:solidFill>
                   <a:srgbClr val="1E293B"/>
                 </a:solidFill>
@@ -5709,7 +5699,7 @@
           </a:p>
           <a:p>
             <a:pPr>
-              <a:defRPr sz="1100" b="1">
+              <a:defRPr sz="1050" b="1">
                 <a:solidFill>
                   <a:srgbClr val="15803D"/>
                 </a:solidFill>
@@ -5720,7 +5710,7 @@
               <a:t>✔ Dimensionality Reduction (42 → 15 features, 64.3%): </a:t>
             </a:r>
             <a:r>
-              <a:rPr sz="1050" b="0">
+              <a:rPr sz="1000" b="0">
                 <a:solidFill>
                   <a:srgbClr val="1E293B"/>
                 </a:solidFill>
@@ -5801,7 +5791,7 @@
         <p:spPr>
           <a:xfrm>
             <a:off x="0" y="0"/>
-            <a:ext cx="12191695" cy="1051560"/>
+            <a:ext cx="12191695" cy="1005840"/>
           </a:xfrm>
           <a:prstGeom prst="rect">
             <a:avLst/>
@@ -5843,8 +5833,8 @@
         </p:nvSpPr>
         <p:spPr>
           <a:xfrm>
-            <a:off x="0" y="1051560"/>
-            <a:ext cx="12191695" cy="54864"/>
+            <a:off x="0" y="1005840"/>
+            <a:ext cx="12191695" cy="45720"/>
           </a:xfrm>
           <a:prstGeom prst="rect">
             <a:avLst/>
@@ -5886,7 +5876,7 @@
         </p:nvSpPr>
         <p:spPr>
           <a:xfrm>
-            <a:off x="731520" y="109728"/>
+            <a:off x="731520" y="73152"/>
             <a:ext cx="10789920" cy="868680"/>
           </a:xfrm>
           <a:prstGeom prst="rect">
@@ -5901,7 +5891,7 @@
           <a:lstStyle/>
           <a:p>
             <a:pPr>
-              <a:defRPr sz="2300" b="1">
+              <a:defRPr sz="2200" b="1">
                 <a:solidFill>
                   <a:srgbClr val="FFFFFF"/>
                 </a:solidFill>
@@ -5914,7 +5904,7 @@
           </a:p>
           <a:p>
             <a:pPr>
-              <a:defRPr sz="1150">
+              <a:defRPr sz="1100">
                 <a:solidFill>
                   <a:srgbClr val="BFDBFE"/>
                 </a:solidFill>
@@ -5935,8 +5925,8 @@
         </p:nvSpPr>
         <p:spPr>
           <a:xfrm>
-            <a:off x="548640" y="1234440"/>
-            <a:ext cx="11094415" cy="5303520"/>
+            <a:off x="548640" y="1143000"/>
+            <a:ext cx="11094415" cy="5486400"/>
           </a:xfrm>
           <a:prstGeom prst="rect">
             <a:avLst/>
@@ -5944,7 +5934,7 @@
           <a:solidFill>
             <a:srgbClr val="FFFFFF"/>
           </a:solidFill>
-          <a:ln w="15240">
+          <a:ln w="13970">
             <a:solidFill>
               <a:srgbClr val="CBD5E1"/>
             </a:solidFill>
@@ -5988,8 +5978,8 @@
         </p:blipFill>
         <p:spPr>
           <a:xfrm>
-            <a:off x="731520" y="1371600"/>
-            <a:ext cx="5303520" cy="4114800"/>
+            <a:off x="731520" y="1280160"/>
+            <a:ext cx="5257800" cy="3977639"/>
           </a:xfrm>
           <a:prstGeom prst="rect">
             <a:avLst/>
@@ -6012,8 +6002,8 @@
         </p:blipFill>
         <p:spPr>
           <a:xfrm>
-            <a:off x="6217920" y="1371600"/>
-            <a:ext cx="5303520" cy="4114800"/>
+            <a:off x="6199632" y="1280160"/>
+            <a:ext cx="5257800" cy="3977639"/>
           </a:xfrm>
           <a:prstGeom prst="rect">
             <a:avLst/>
@@ -6028,8 +6018,8 @@
         </p:nvSpPr>
         <p:spPr>
           <a:xfrm>
-            <a:off x="731520" y="5577840"/>
-            <a:ext cx="5303520" cy="822960"/>
+            <a:off x="731520" y="5321808"/>
+            <a:ext cx="5257800" cy="1188720"/>
           </a:xfrm>
           <a:prstGeom prst="rect">
             <a:avLst/>
@@ -6043,7 +6033,7 @@
           <a:lstStyle/>
           <a:p>
             <a:pPr>
-              <a:defRPr sz="1150" b="1">
+              <a:defRPr sz="1100" b="1">
                 <a:solidFill>
                   <a:srgbClr val="1E3A8A"/>
                 </a:solidFill>
@@ -6056,7 +6046,7 @@
           </a:p>
           <a:p>
             <a:pPr>
-              <a:defRPr sz="950">
+              <a:defRPr sz="900">
                 <a:solidFill>
                   <a:srgbClr val="475569"/>
                 </a:solidFill>
@@ -6084,8 +6074,8 @@
         </p:nvSpPr>
         <p:spPr>
           <a:xfrm>
-            <a:off x="6217920" y="5577840"/>
-            <a:ext cx="5303520" cy="822960"/>
+            <a:off x="6199632" y="5321808"/>
+            <a:ext cx="5257800" cy="1188720"/>
           </a:xfrm>
           <a:prstGeom prst="rect">
             <a:avLst/>
@@ -6099,7 +6089,7 @@
           <a:lstStyle/>
           <a:p>
             <a:pPr>
-              <a:defRPr sz="1150" b="1">
+              <a:defRPr sz="1100" b="1">
                 <a:solidFill>
                   <a:srgbClr val="1E3A8A"/>
                 </a:solidFill>
@@ -6112,7 +6102,7 @@
           </a:p>
           <a:p>
             <a:pPr>
-              <a:defRPr sz="950">
+              <a:defRPr sz="900">
                 <a:solidFill>
                   <a:srgbClr val="475569"/>
                 </a:solidFill>
@@ -6202,7 +6192,7 @@
         <p:spPr>
           <a:xfrm>
             <a:off x="0" y="0"/>
-            <a:ext cx="12191695" cy="1051560"/>
+            <a:ext cx="12191695" cy="1005840"/>
           </a:xfrm>
           <a:prstGeom prst="rect">
             <a:avLst/>
@@ -6244,8 +6234,8 @@
         </p:nvSpPr>
         <p:spPr>
           <a:xfrm>
-            <a:off x="0" y="1051560"/>
-            <a:ext cx="12191695" cy="54864"/>
+            <a:off x="0" y="1005840"/>
+            <a:ext cx="12191695" cy="45720"/>
           </a:xfrm>
           <a:prstGeom prst="rect">
             <a:avLst/>
@@ -6287,7 +6277,7 @@
         </p:nvSpPr>
         <p:spPr>
           <a:xfrm>
-            <a:off x="731520" y="109728"/>
+            <a:off x="731520" y="73152"/>
             <a:ext cx="10789920" cy="868680"/>
           </a:xfrm>
           <a:prstGeom prst="rect">
@@ -6302,7 +6292,7 @@
           <a:lstStyle/>
           <a:p>
             <a:pPr>
-              <a:defRPr sz="2300" b="1">
+              <a:defRPr sz="2200" b="1">
                 <a:solidFill>
                   <a:srgbClr val="FFFFFF"/>
                 </a:solidFill>
@@ -6315,7 +6305,7 @@
           </a:p>
           <a:p>
             <a:pPr>
-              <a:defRPr sz="1150">
+              <a:defRPr sz="1100">
                 <a:solidFill>
                   <a:srgbClr val="BFDBFE"/>
                 </a:solidFill>
@@ -6336,8 +6326,8 @@
         </p:nvSpPr>
         <p:spPr>
           <a:xfrm>
-            <a:off x="548640" y="1234440"/>
-            <a:ext cx="11094415" cy="5303520"/>
+            <a:off x="548640" y="1143000"/>
+            <a:ext cx="11094415" cy="5486400"/>
           </a:xfrm>
           <a:prstGeom prst="rect">
             <a:avLst/>
@@ -6345,7 +6335,7 @@
           <a:solidFill>
             <a:srgbClr val="FFFFFF"/>
           </a:solidFill>
-          <a:ln w="15240">
+          <a:ln w="13970">
             <a:solidFill>
               <a:srgbClr val="CBD5E1"/>
             </a:solidFill>
@@ -6389,8 +6379,8 @@
         </p:blipFill>
         <p:spPr>
           <a:xfrm>
-            <a:off x="731520" y="1353312"/>
-            <a:ext cx="5212080" cy="2331720"/>
+            <a:off x="731520" y="1261872"/>
+            <a:ext cx="5257800" cy="2395728"/>
           </a:xfrm>
           <a:prstGeom prst="rect">
             <a:avLst/>
@@ -6413,8 +6403,8 @@
         </p:blipFill>
         <p:spPr>
           <a:xfrm>
-            <a:off x="6217920" y="1353312"/>
-            <a:ext cx="5212080" cy="2331720"/>
+            <a:off x="6199632" y="1261872"/>
+            <a:ext cx="5257800" cy="2395728"/>
           </a:xfrm>
           <a:prstGeom prst="rect">
             <a:avLst/>
@@ -6437,8 +6427,8 @@
         </p:blipFill>
         <p:spPr>
           <a:xfrm>
-            <a:off x="731520" y="3977639"/>
-            <a:ext cx="5212080" cy="2240280"/>
+            <a:off x="731520" y="3767328"/>
+            <a:ext cx="5257800" cy="2487168"/>
           </a:xfrm>
           <a:prstGeom prst="rect">
             <a:avLst/>
@@ -6461,8 +6451,8 @@
         </p:blipFill>
         <p:spPr>
           <a:xfrm>
-            <a:off x="6217920" y="4069080"/>
-            <a:ext cx="5212080" cy="2057400"/>
+            <a:off x="6537960" y="3749039"/>
+            <a:ext cx="4572000" cy="2514600"/>
           </a:xfrm>
           <a:prstGeom prst="rect">
             <a:avLst/>
@@ -6477,8 +6467,8 @@
         </p:nvSpPr>
         <p:spPr>
           <a:xfrm>
-            <a:off x="731520" y="6263640"/>
-            <a:ext cx="10698480" cy="274320"/>
+            <a:off x="731520" y="6309360"/>
+            <a:ext cx="10698480" cy="292608"/>
           </a:xfrm>
           <a:prstGeom prst="rect">
             <a:avLst/>
@@ -6492,7 +6482,7 @@
           <a:lstStyle/>
           <a:p>
             <a:pPr algn="ctr">
-              <a:defRPr sz="1050" b="1">
+              <a:defRPr sz="1000" b="1">
                 <a:solidFill>
                   <a:srgbClr val="1E3A8A"/>
                 </a:solidFill>

</xml_diff>